<commit_message>
Bug 1.0 refactoring in 0.3
</commit_message>
<xml_diff>
--- a/ppt/RAG11-Persistence-Agent.pptx
+++ b/ppt/RAG11-Persistence-Agent.pptx
@@ -5,10 +5,10 @@
     <p:sldMasterId id="2147483653" r:id="rId1"/>
   </p:sldMasterIdLst>
   <p:notesMasterIdLst>
-    <p:notesMasterId r:id="rId15"/>
+    <p:notesMasterId r:id="rId12"/>
   </p:notesMasterIdLst>
   <p:handoutMasterIdLst>
-    <p:handoutMasterId r:id="rId16"/>
+    <p:handoutMasterId r:id="rId13"/>
   </p:handoutMasterIdLst>
   <p:sldIdLst>
     <p:sldId id="264" r:id="rId2"/>
@@ -20,10 +20,7 @@
     <p:sldId id="282" r:id="rId8"/>
     <p:sldId id="293" r:id="rId9"/>
     <p:sldId id="284" r:id="rId10"/>
-    <p:sldId id="283" r:id="rId11"/>
-    <p:sldId id="285" r:id="rId12"/>
-    <p:sldId id="286" r:id="rId13"/>
-    <p:sldId id="288" r:id="rId14"/>
+    <p:sldId id="288" r:id="rId11"/>
   </p:sldIdLst>
   <p:sldSz cx="9144000" cy="6858000" type="screen4x3"/>
   <p:notesSz cx="6648450" cy="9782175"/>
@@ -3802,426 +3799,6 @@
           <p:cNvPr id="2" name="Titre 1">
             <a:extLst>
               <a:ext uri="{FF2B5EF4-FFF2-40B4-BE49-F238E27FC236}">
-                <a16:creationId xmlns:a16="http://schemas.microsoft.com/office/drawing/2014/main" id="{053AE19E-D7A7-0E83-F8DA-E918DFF2BDEA}"/>
-              </a:ext>
-            </a:extLst>
-          </p:cNvPr>
-          <p:cNvSpPr>
-            <a:spLocks noGrp="1"/>
-          </p:cNvSpPr>
-          <p:nvPr>
-            <p:ph type="title"/>
-          </p:nvPr>
-        </p:nvSpPr>
-        <p:spPr/>
-        <p:txBody>
-          <a:bodyPr/>
-          <a:lstStyle/>
-          <a:p>
-            <a:r>
-              <a:rPr lang="fr-FR" dirty="0"/>
-              <a:t>Agent</a:t>
-            </a:r>
-          </a:p>
-        </p:txBody>
-      </p:sp>
-      <p:sp>
-        <p:nvSpPr>
-          <p:cNvPr id="3" name="Espace réservé du contenu 2">
-            <a:extLst>
-              <a:ext uri="{FF2B5EF4-FFF2-40B4-BE49-F238E27FC236}">
-                <a16:creationId xmlns:a16="http://schemas.microsoft.com/office/drawing/2014/main" id="{D2E8FFFA-B049-8E1A-76C8-AFB0D2E44498}"/>
-              </a:ext>
-            </a:extLst>
-          </p:cNvPr>
-          <p:cNvSpPr>
-            <a:spLocks noGrp="1"/>
-          </p:cNvSpPr>
-          <p:nvPr>
-            <p:ph idx="1"/>
-          </p:nvPr>
-        </p:nvSpPr>
-        <p:spPr/>
-        <p:txBody>
-          <a:bodyPr/>
-          <a:lstStyle/>
-          <a:p>
-            <a:r>
-              <a:rPr lang="fr-FR" dirty="0"/>
-              <a:t>Supposons une requête LLM classique</a:t>
-            </a:r>
-          </a:p>
-          <a:p>
-            <a:endParaRPr lang="fr-FR" dirty="0"/>
-          </a:p>
-          <a:p>
-            <a:endParaRPr lang="fr-FR" dirty="0"/>
-          </a:p>
-          <a:p>
-            <a:endParaRPr lang="fr-FR" dirty="0"/>
-          </a:p>
-          <a:p>
-            <a:r>
-              <a:rPr lang="fr-FR" dirty="0"/>
-              <a:t>Un agent permet d'enrichir la requête LLM par la méthode de l'agent</a:t>
-            </a:r>
-          </a:p>
-        </p:txBody>
-      </p:sp>
-      <p:pic>
-        <p:nvPicPr>
-          <p:cNvPr id="5" name="Image 4">
-            <a:extLst>
-              <a:ext uri="{FF2B5EF4-FFF2-40B4-BE49-F238E27FC236}">
-                <a16:creationId xmlns:a16="http://schemas.microsoft.com/office/drawing/2014/main" id="{6500F459-FD1D-7884-E515-56D3F4BCA030}"/>
-              </a:ext>
-            </a:extLst>
-          </p:cNvPr>
-          <p:cNvPicPr>
-            <a:picLocks noChangeAspect="1"/>
-          </p:cNvPicPr>
-          <p:nvPr/>
-        </p:nvPicPr>
-        <p:blipFill>
-          <a:blip r:embed="rId2"/>
-          <a:stretch>
-            <a:fillRect/>
-          </a:stretch>
-        </p:blipFill>
-        <p:spPr>
-          <a:xfrm>
-            <a:off x="2411760" y="2060848"/>
-            <a:ext cx="4124901" cy="1152686"/>
-          </a:xfrm>
-          <a:prstGeom prst="rect">
-            <a:avLst/>
-          </a:prstGeom>
-        </p:spPr>
-      </p:pic>
-      <p:pic>
-        <p:nvPicPr>
-          <p:cNvPr id="7" name="Image 6">
-            <a:extLst>
-              <a:ext uri="{FF2B5EF4-FFF2-40B4-BE49-F238E27FC236}">
-                <a16:creationId xmlns:a16="http://schemas.microsoft.com/office/drawing/2014/main" id="{49856640-9286-AACA-76D7-A66B9006286F}"/>
-              </a:ext>
-            </a:extLst>
-          </p:cNvPr>
-          <p:cNvPicPr>
-            <a:picLocks noChangeAspect="1"/>
-          </p:cNvPicPr>
-          <p:nvPr/>
-        </p:nvPicPr>
-        <p:blipFill>
-          <a:blip r:embed="rId3"/>
-          <a:stretch>
-            <a:fillRect/>
-          </a:stretch>
-        </p:blipFill>
-        <p:spPr>
-          <a:xfrm>
-            <a:off x="1187624" y="4721223"/>
-            <a:ext cx="6725589" cy="1448002"/>
-          </a:xfrm>
-          <a:prstGeom prst="rect">
-            <a:avLst/>
-          </a:prstGeom>
-        </p:spPr>
-      </p:pic>
-    </p:spTree>
-    <p:extLst>
-      <p:ext uri="{BB962C8B-B14F-4D97-AF65-F5344CB8AC3E}">
-        <p14:creationId xmlns:p14="http://schemas.microsoft.com/office/powerpoint/2010/main" val="1009830935"/>
-      </p:ext>
-    </p:extLst>
-  </p:cSld>
-  <p:clrMapOvr>
-    <a:masterClrMapping/>
-  </p:clrMapOvr>
-</p:sld>
-</file>
-
-<file path=ppt/slides/slide11.xml><?xml version="1.0" encoding="utf-8"?>
-<p:sld xmlns:a="http://schemas.openxmlformats.org/drawingml/2006/main" xmlns:r="http://schemas.openxmlformats.org/officeDocument/2006/relationships" xmlns:p="http://schemas.openxmlformats.org/presentationml/2006/main">
-  <p:cSld>
-    <p:spTree>
-      <p:nvGrpSpPr>
-        <p:cNvPr id="1" name=""/>
-        <p:cNvGrpSpPr/>
-        <p:nvPr/>
-      </p:nvGrpSpPr>
-      <p:grpSpPr>
-        <a:xfrm>
-          <a:off x="0" y="0"/>
-          <a:ext cx="0" cy="0"/>
-          <a:chOff x="0" y="0"/>
-          <a:chExt cx="0" cy="0"/>
-        </a:xfrm>
-      </p:grpSpPr>
-      <p:sp>
-        <p:nvSpPr>
-          <p:cNvPr id="2" name="Titre 1">
-            <a:extLst>
-              <a:ext uri="{FF2B5EF4-FFF2-40B4-BE49-F238E27FC236}">
-                <a16:creationId xmlns:a16="http://schemas.microsoft.com/office/drawing/2014/main" id="{626F7EE6-7E1B-5825-8754-6C77409422F8}"/>
-              </a:ext>
-            </a:extLst>
-          </p:cNvPr>
-          <p:cNvSpPr>
-            <a:spLocks noGrp="1"/>
-          </p:cNvSpPr>
-          <p:nvPr>
-            <p:ph type="title"/>
-          </p:nvPr>
-        </p:nvSpPr>
-        <p:spPr/>
-        <p:txBody>
-          <a:bodyPr/>
-          <a:lstStyle/>
-          <a:p>
-            <a:r>
-              <a:rPr lang="fr-FR" dirty="0"/>
-              <a:t>Agent + RAG</a:t>
-            </a:r>
-          </a:p>
-        </p:txBody>
-      </p:sp>
-      <p:sp>
-        <p:nvSpPr>
-          <p:cNvPr id="3" name="Espace réservé du contenu 2">
-            <a:extLst>
-              <a:ext uri="{FF2B5EF4-FFF2-40B4-BE49-F238E27FC236}">
-                <a16:creationId xmlns:a16="http://schemas.microsoft.com/office/drawing/2014/main" id="{E3D2D3AE-96B6-89FA-63AA-1CCED998DB64}"/>
-              </a:ext>
-            </a:extLst>
-          </p:cNvPr>
-          <p:cNvSpPr>
-            <a:spLocks noGrp="1"/>
-          </p:cNvSpPr>
-          <p:nvPr>
-            <p:ph idx="1"/>
-          </p:nvPr>
-        </p:nvSpPr>
-        <p:spPr/>
-        <p:txBody>
-          <a:bodyPr/>
-          <a:lstStyle/>
-          <a:p>
-            <a:r>
-              <a:rPr lang="fr-FR" dirty="0"/>
-              <a:t>Un Agent est indépendant du RAG</a:t>
-            </a:r>
-          </a:p>
-          <a:p>
-            <a:pPr lvl="1"/>
-            <a:r>
-              <a:rPr lang="fr-FR" dirty="0"/>
-              <a:t>Peut compléter du RAG</a:t>
-            </a:r>
-          </a:p>
-          <a:p>
-            <a:pPr lvl="1"/>
-            <a:r>
-              <a:rPr lang="fr-FR" dirty="0"/>
-              <a:t>Il suffit de mettre le RAG dans une fonction</a:t>
-            </a:r>
-          </a:p>
-          <a:p>
-            <a:pPr lvl="1"/>
-            <a:endParaRPr lang="fr-FR" dirty="0"/>
-          </a:p>
-        </p:txBody>
-      </p:sp>
-      <p:pic>
-        <p:nvPicPr>
-          <p:cNvPr id="7" name="Image 6">
-            <a:extLst>
-              <a:ext uri="{FF2B5EF4-FFF2-40B4-BE49-F238E27FC236}">
-                <a16:creationId xmlns:a16="http://schemas.microsoft.com/office/drawing/2014/main" id="{2B423BD9-3EAB-8AFF-0220-56A980CD8FF7}"/>
-              </a:ext>
-            </a:extLst>
-          </p:cNvPr>
-          <p:cNvPicPr>
-            <a:picLocks noChangeAspect="1"/>
-          </p:cNvPicPr>
-          <p:nvPr/>
-        </p:nvPicPr>
-        <p:blipFill>
-          <a:blip r:embed="rId2"/>
-          <a:stretch>
-            <a:fillRect/>
-          </a:stretch>
-        </p:blipFill>
-        <p:spPr>
-          <a:xfrm>
-            <a:off x="1221446" y="2996952"/>
-            <a:ext cx="6839905" cy="3229426"/>
-          </a:xfrm>
-          <a:prstGeom prst="rect">
-            <a:avLst/>
-          </a:prstGeom>
-        </p:spPr>
-      </p:pic>
-    </p:spTree>
-    <p:extLst>
-      <p:ext uri="{BB962C8B-B14F-4D97-AF65-F5344CB8AC3E}">
-        <p14:creationId xmlns:p14="http://schemas.microsoft.com/office/powerpoint/2010/main" val="430089590"/>
-      </p:ext>
-    </p:extLst>
-  </p:cSld>
-  <p:clrMapOvr>
-    <a:masterClrMapping/>
-  </p:clrMapOvr>
-</p:sld>
-</file>
-
-<file path=ppt/slides/slide12.xml><?xml version="1.0" encoding="utf-8"?>
-<p:sld xmlns:a="http://schemas.openxmlformats.org/drawingml/2006/main" xmlns:r="http://schemas.openxmlformats.org/officeDocument/2006/relationships" xmlns:p="http://schemas.openxmlformats.org/presentationml/2006/main">
-  <p:cSld>
-    <p:spTree>
-      <p:nvGrpSpPr>
-        <p:cNvPr id="1" name=""/>
-        <p:cNvGrpSpPr/>
-        <p:nvPr/>
-      </p:nvGrpSpPr>
-      <p:grpSpPr>
-        <a:xfrm>
-          <a:off x="0" y="0"/>
-          <a:ext cx="0" cy="0"/>
-          <a:chOff x="0" y="0"/>
-          <a:chExt cx="0" cy="0"/>
-        </a:xfrm>
-      </p:grpSpPr>
-      <p:sp>
-        <p:nvSpPr>
-          <p:cNvPr id="2" name="Titre 1">
-            <a:extLst>
-              <a:ext uri="{FF2B5EF4-FFF2-40B4-BE49-F238E27FC236}">
-                <a16:creationId xmlns:a16="http://schemas.microsoft.com/office/drawing/2014/main" id="{02DCBE16-BFBA-9F6D-2476-F57EB0BD6CBB}"/>
-              </a:ext>
-            </a:extLst>
-          </p:cNvPr>
-          <p:cNvSpPr>
-            <a:spLocks noGrp="1"/>
-          </p:cNvSpPr>
-          <p:nvPr>
-            <p:ph type="title"/>
-          </p:nvPr>
-        </p:nvSpPr>
-        <p:spPr/>
-        <p:txBody>
-          <a:bodyPr/>
-          <a:lstStyle/>
-          <a:p>
-            <a:r>
-              <a:rPr lang="fr-FR" dirty="0"/>
-              <a:t>Agent + RAG</a:t>
-            </a:r>
-          </a:p>
-        </p:txBody>
-      </p:sp>
-      <p:sp>
-        <p:nvSpPr>
-          <p:cNvPr id="3" name="Espace réservé du contenu 2">
-            <a:extLst>
-              <a:ext uri="{FF2B5EF4-FFF2-40B4-BE49-F238E27FC236}">
-                <a16:creationId xmlns:a16="http://schemas.microsoft.com/office/drawing/2014/main" id="{BC00A1AF-10C0-974E-68B0-1E0BB27431E4}"/>
-              </a:ext>
-            </a:extLst>
-          </p:cNvPr>
-          <p:cNvSpPr>
-            <a:spLocks noGrp="1"/>
-          </p:cNvSpPr>
-          <p:nvPr>
-            <p:ph idx="1"/>
-          </p:nvPr>
-        </p:nvSpPr>
-        <p:spPr/>
-        <p:txBody>
-          <a:bodyPr/>
-          <a:lstStyle/>
-          <a:p>
-            <a:r>
-              <a:rPr lang="fr-FR"/>
-              <a:t>LA prompt </a:t>
-            </a:r>
-            <a:r>
-              <a:rPr lang="fr-FR" dirty="0"/>
-              <a:t>suivant va effectuer un RAG puis un appel à la fonction </a:t>
-            </a:r>
-            <a:r>
-              <a:rPr lang="fr-FR" dirty="0" err="1"/>
-              <a:t>multiply</a:t>
-            </a:r>
-            <a:endParaRPr lang="fr-FR" dirty="0"/>
-          </a:p>
-        </p:txBody>
-      </p:sp>
-      <p:pic>
-        <p:nvPicPr>
-          <p:cNvPr id="5" name="Image 4">
-            <a:extLst>
-              <a:ext uri="{FF2B5EF4-FFF2-40B4-BE49-F238E27FC236}">
-                <a16:creationId xmlns:a16="http://schemas.microsoft.com/office/drawing/2014/main" id="{86E79563-ECC2-8F67-34DA-2A52D023C82E}"/>
-              </a:ext>
-            </a:extLst>
-          </p:cNvPr>
-          <p:cNvPicPr>
-            <a:picLocks noChangeAspect="1"/>
-          </p:cNvPicPr>
-          <p:nvPr/>
-        </p:nvPicPr>
-        <p:blipFill>
-          <a:blip r:embed="rId2"/>
-          <a:stretch>
-            <a:fillRect/>
-          </a:stretch>
-        </p:blipFill>
-        <p:spPr>
-          <a:xfrm>
-            <a:off x="1904628" y="2785973"/>
-            <a:ext cx="5334744" cy="1286054"/>
-          </a:xfrm>
-          <a:prstGeom prst="rect">
-            <a:avLst/>
-          </a:prstGeom>
-        </p:spPr>
-      </p:pic>
-    </p:spTree>
-    <p:extLst>
-      <p:ext uri="{BB962C8B-B14F-4D97-AF65-F5344CB8AC3E}">
-        <p14:creationId xmlns:p14="http://schemas.microsoft.com/office/powerpoint/2010/main" val="2385522685"/>
-      </p:ext>
-    </p:extLst>
-  </p:cSld>
-  <p:clrMapOvr>
-    <a:masterClrMapping/>
-  </p:clrMapOvr>
-</p:sld>
-</file>
-
-<file path=ppt/slides/slide13.xml><?xml version="1.0" encoding="utf-8"?>
-<p:sld xmlns:a="http://schemas.openxmlformats.org/drawingml/2006/main" xmlns:r="http://schemas.openxmlformats.org/officeDocument/2006/relationships" xmlns:p="http://schemas.openxmlformats.org/presentationml/2006/main">
-  <p:cSld>
-    <p:spTree>
-      <p:nvGrpSpPr>
-        <p:cNvPr id="1" name=""/>
-        <p:cNvGrpSpPr/>
-        <p:nvPr/>
-      </p:nvGrpSpPr>
-      <p:grpSpPr>
-        <a:xfrm>
-          <a:off x="0" y="0"/>
-          <a:ext cx="0" cy="0"/>
-          <a:chOff x="0" y="0"/>
-          <a:chExt cx="0" cy="0"/>
-        </a:xfrm>
-      </p:grpSpPr>
-      <p:sp>
-        <p:nvSpPr>
-          <p:cNvPr id="2" name="Titre 1">
-            <a:extLst>
-              <a:ext uri="{FF2B5EF4-FFF2-40B4-BE49-F238E27FC236}">
                 <a16:creationId xmlns:a16="http://schemas.microsoft.com/office/drawing/2014/main" id="{2370A0E2-49A5-7C2E-92FD-CFE9D4C771E3}"/>
               </a:ext>
             </a:extLst>
@@ -4276,9 +3853,32 @@
           <a:lstStyle/>
           <a:p>
             <a:r>
+              <a:rPr lang="fr-FR" dirty="0"/>
+              <a:t>Il existe des agents préfabriqués</a:t>
+            </a:r>
+          </a:p>
+          <a:p>
+            <a:r>
+              <a:rPr lang="fr-FR" dirty="0" err="1"/>
+              <a:t>Tavily</a:t>
+            </a:r>
+            <a:r>
+              <a:rPr lang="fr-FR" dirty="0"/>
+              <a:t> </a:t>
+            </a:r>
+            <a:r>
+              <a:rPr lang="fr-FR" dirty="0" err="1"/>
+              <a:t>Search</a:t>
+            </a:r>
+            <a:r>
+              <a:rPr lang="fr-FR" dirty="0"/>
+              <a:t> est un agent de </a:t>
+            </a:r>
+            <a:r>
               <a:rPr lang="fr-FR"/>
-              <a:t>Recherche Web</a:t>
-            </a:r>
+              <a:t>recherche spécialisé pour les LLM</a:t>
+            </a:r>
+            <a:endParaRPr lang="fr-FR" dirty="0"/>
           </a:p>
         </p:txBody>
       </p:sp>
@@ -5529,6 +5129,36 @@
           <a:xfrm>
             <a:off x="7236296" y="1412776"/>
             <a:ext cx="1209844" cy="4582164"/>
+          </a:xfrm>
+          <a:prstGeom prst="rect">
+            <a:avLst/>
+          </a:prstGeom>
+        </p:spPr>
+      </p:pic>
+      <p:pic>
+        <p:nvPicPr>
+          <p:cNvPr id="7" name="Image 6">
+            <a:extLst>
+              <a:ext uri="{FF2B5EF4-FFF2-40B4-BE49-F238E27FC236}">
+                <a16:creationId xmlns:a16="http://schemas.microsoft.com/office/drawing/2014/main" id="{65AEA008-7EF0-1DF7-9F35-2E69CE3BFEEF}"/>
+              </a:ext>
+            </a:extLst>
+          </p:cNvPr>
+          <p:cNvPicPr>
+            <a:picLocks noChangeAspect="1"/>
+          </p:cNvPicPr>
+          <p:nvPr/>
+        </p:nvPicPr>
+        <p:blipFill>
+          <a:blip r:embed="rId3"/>
+          <a:stretch>
+            <a:fillRect/>
+          </a:stretch>
+        </p:blipFill>
+        <p:spPr>
+          <a:xfrm>
+            <a:off x="125289" y="4082273"/>
+            <a:ext cx="6174903" cy="1366264"/>
           </a:xfrm>
           <a:prstGeom prst="rect">
             <a:avLst/>

</xml_diff>